<commit_message>
docs(report): refine v0.5 AI engineering deck
</commit_message>
<xml_diff>
--- a/docs/report/ai-redefines-software-development-presentation/ai-redefines-software-development-v0.5.pptx
+++ b/docs/report/ai-redefines-software-development-presentation/ai-redefines-software-development-v0.5.pptx
@@ -18,10 +18,9 @@
     <p:sldId id="266" r:id="rId12"/>
     <p:sldId id="267" r:id="rId13"/>
     <p:sldId id="268" r:id="rId14"/>
-    <p:sldId id="269" r:id="rId15"/>
   </p:sldIdLst>
   <p:notesMasterIdLst>
-    <p:notesMasterId r:id="rId16"/>
+    <p:notesMasterId r:id="rId15"/>
   </p:notesMasterIdLst>
   <p:sldSz cx="12191695" cy="6858000"/>
   <p:notesSz cx="6858000" cy="12191695"/>
@@ -608,12 +607,12 @@
           <a:p>
             <a:r>
               <a:rPr lang="en-US" dirty="0"/>
-              <a:t>第 10 页：下一代工程方法：让 DFX 与 TDD 变成 Agent 协议
-建议时长：约 1.3 分钟
-页内重点：回应 DFX/TDD 新形态：非特定工程的 AI 下解决方案、细化军规、用例形态升级。
-互动提问：如果代码军规仍会被幻觉绕过，下一层护栏是什么？
-讲稿：这里可以做一个前瞻判断：AI 时代的 DFX 不会只是 Design for X 的静态清单，而会变成一组可执行的 Agent 协议。比如性能、可观测性、安全、可维护性，不再只写在规范里，而是以检查项、基准、trace、回归用例、发布预算的形式进入 Agent 工作流。TDD 也会扩展：不只是先写单元测试再写实现，而是先定义失败证据、属性约束、运行观测和评估集，再让 Agent 在这些证据边界里修改。代码军规仍会有幻觉，所以规则要更细，但更关键的是规则要可执行：能被工具检查、能被 trace 回放、能被 review 独立仲裁。
-转场：把这些方法落到 BitFun，就能看到一个 Agent 工程系统的雏形。</a:t>
+              <a:t>第 10 页：把 AI 开发组织成可治理工作流
+建议时长：约 1.5 分钟
+页内重点：把质量治理落到可执行方法：Spec/Issue -&gt; Agent Worktree -&gt; Evidence Packet -&gt; Independent Review -&gt; Gate/Merge。
+互动提问：如果多个 Agent 同时参与，团队靠什么判断一个变更可以继续前进？
+讲稿：回到 BitFun，它不是要证明某个模型更强，而是展示一个团队工作流的雏形。更可落地的做法是把一次 AI 开发压成五个稳定环节：第一，任务从 Issue 或 Spec 进入，明确目标、非目标和风险边界；第二，Agent 在隔离工作区执行，避免把探索过程直接污染主分支；第三，执行结束必须生成证据包，包括 diff 摘要、测试结果、日志、trace、未决风险和回滚路径；第四，评审要角色分离，发现问题、仲裁问题、修复问题、验证修复尽量不要由同一个角色闭环；第五，阶段门禁决定能否进入 PR、合并或发布。这里的关键不是记录每一步操作，而是把复杂过程压缩成团队能读、能审、能追责的交付对象和证据。
+转场：最后，我们把视角切回开发者：人在这样的系统里到底做什么。</a:t>
             </a:r>
             <a:endParaRPr lang="en-US" dirty="0"/>
           </a:p>
@@ -701,12 +700,12 @@
           <a:p>
             <a:r>
               <a:rPr lang="en-US" dirty="0"/>
-              <a:t>第 11 页：BitFun 的价值：把开发过程组织成团队工作流
-建议时长：约 1.4 分钟
-页内重点：把第九页落到可执行方法：Spec/Issue -&gt; Agent Worktree -&gt; Evidence Packet -&gt; Independent Review -&gt; Gate/Merge。
-互动提问：如果多个 Agent 同时参与，团队靠什么判断一个变更可以继续前进？
-讲稿：回到 BitFun，它不是要证明某个模型更强，而是展示一个团队工作流的雏形。更可落地的做法是把一次 AI 开发压成五个稳定环节：第一，任务从 Issue 或 Spec 进入，明确目标、非目标和风险边界；第二，Agent 在隔离工作区执行，避免把探索过程直接污染主分支；第三，执行结束必须生成证据包，包括 diff 摘要、测试结果、日志、trace、未决风险和回滚路径；第四，评审要角色分离，发现问题、仲裁问题、修复问题、验证修复尽量不要由同一个角色闭环；第五，阶段门禁决定能否进入 PR、合并或发布。这里的关键不是记录每一步操作，而是把复杂过程压缩成团队能读、能审、能追责的交付对象和证据。
-转场：最后，我们把视角切回开发者：人在这样的系统里到底做什么。</a:t>
+              <a:t>第 11 页：开发者角色：在新工程系统中找准位置
+建议时长：约 1.5 分钟
+页内重点：收敛为四步，明确人在各阶段和 AI 在各阶段的角色。
+互动提问：AI 参与每个阶段后，人类开发者最不可替代的技能是什么？
+讲稿：对学生来说，这页很关键：未来不是“人写代码，AI 帮忙补全”，而是人在不同阶段承担不同关键角色。第一步是定义问题，人负责价值判断、非目标和风险边界，AI 可以帮助整理信息和生成备选方案。第二步是组织上下文，人负责架构取舍和事实源选择，AI 负责检索、摘要和草拟计划。第三步是编排执行，人负责设置权限、节奏、验证矩阵和停止条件，AI 负责生成、修改、运行和反馈。第四步是证据放行，人负责最终责任、质量解释和复盘沉淀，AI 提供 trace、diff、测试结果和改进建议。所以编程基础仍重要，但能力结构会从语法实现，升级到问题定义、系统判断、证据审查和协作治理。
+转场：最后把视角落到刚入职场的同学：AI 时代哪些能力更值得优先练。</a:t>
             </a:r>
             <a:endParaRPr lang="en-US" dirty="0"/>
           </a:p>
@@ -794,12 +793,12 @@
           <a:p>
             <a:r>
               <a:rPr lang="en-US" dirty="0"/>
-              <a:t>第 12 页：开发者角色：在新工程系统中找准位置
-建议时长：约 1.5 分钟
-页内重点：收敛为四步，明确人在各阶段和 AI 在各阶段的角色。
-互动提问：AI 参与每个阶段后，人类开发者最不可替代的技能是什么？
-讲稿：对学生来说，这页很关键：未来不是“人写代码，AI 帮忙补全”，而是人在不同阶段承担不同关键角色。第一步是定义问题，人负责价值判断、非目标和风险边界，AI 可以帮助整理信息和生成备选方案。第二步是组织上下文，人负责架构取舍和事实源选择，AI 负责检索、摘要和草拟计划。第三步是编排执行，人负责设置权限、节奏、验证矩阵和停止条件，AI 负责生成、修改、运行和反馈。第四步是证据放行，人负责最终责任、质量解释和复盘沉淀，AI 提供 trace、diff、测试结果和改进建议。所以编程基础仍重要，但能力结构会从语法实现，升级到问题定义、系统判断、证据审查和协作治理。
-转场：最后把视角落到刚入职场的同学：AI 时代哪些能力更值得优先练。</a:t>
+              <a:t>第 12 页：刚入职场：四个能力方向
+建议时长：约 1.1 分钟
+页内重点：结合最新调研与论文，把开发者角色变化落到新人工程师可执行的能力方向。
+互动提问：当 AI 可以帮你更快完成任务，第一年最应该刻意训练什么？
+讲稿：最后把问题落到刚入职场的同学。外部信号其实很一致：Stack Overflow 2025 里 84% 开发者使用或计划使用 AI，但 46% 不信任 AI 输出准确性；Anthropic 2026 的受控实验显示，使用 AI 的参与者在刚学新库后的概念测验中低 17%，尤其是调试和理解能力受影响；Sonar 2026 则显示 AI 已经占到相当比例的提交代码，但只有不到一半开发者总是提交前验证。也就是说，新人的问题不是要不要用 AI，而是如何不把成长路径外包给 AI。这里给四个更可执行的方向。第一，保留代码读写与调试基本功：至少能解释核心实现、能复现错误、能定位边界条件。第二，训练证据驱动交付：把测试、CI、日志、trace、review 作为交付的一部分，而不是写完代码后的附属品。第三，理解需求与用户场景：软件工程师不会只承担单纯开发角色，要逐步理解用户路径、产品定位、体验约束和验收标准，才能把 AI 生成结果放进正确问题里。第四，承担责任边界：AI 可以生成和修复，人仍然要判断该不该做、能不能合、出了问题如何解释。可以把它留成讨论题：新人第一年应该追求更多产出，还是更多可解释的判断？哪些任务适合交给 AI，哪些任务必须自己亲手做一遍？
+转场：最后进入 Q&amp;A。</a:t>
             </a:r>
             <a:endParaRPr lang="en-US" dirty="0"/>
           </a:p>
@@ -887,100 +886,7 @@
           <a:p>
             <a:r>
               <a:rPr lang="en-US" dirty="0"/>
-              <a:t>第 13 页：刚入职场：四个能力方向
-建议时长：约 1.1 分钟
-页内重点：结合最新调研与论文，把开发者角色变化落到新人工程师可执行的能力方向。
-互动提问：当 AI 可以帮你更快完成任务，第一年最应该刻意训练什么？
-讲稿：最后把问题落到刚入职场的同学。外部信号其实很一致：Stack Overflow 2025 里 84% 开发者使用或计划使用 AI，但 46% 不信任 AI 输出准确性；Anthropic 2026 的受控实验显示，使用 AI 的参与者在刚学新库后的概念测验中低 17%，尤其是调试和理解能力受影响；Sonar 2026 则显示 AI 已经占到相当比例的提交代码，但只有不到一半开发者总是提交前验证。也就是说，新人的问题不是要不要用 AI，而是如何不把成长路径外包给 AI。这里给四个更可执行的方向。第一，保留代码读写与调试基本功：至少能解释核心实现、能复现错误、能定位边界条件。第二，训练证据驱动交付：把测试、CI、日志、trace、review 作为交付的一部分，而不是写完代码后的附属品。第三，学习上下文与 Artifact 组织：会写清楚需求、约束、验收、ADR、风险说明，因为 Agent 的质量高度依赖工程上下文。第四，承担责任边界：AI 可以生成和修复，人仍然要判断该不该做、能不能合、出了问题如何解释。可以把它留成讨论题：新人第一年应该追求更多产出，还是更多可解释的判断？哪些任务适合交给 AI，哪些任务必须自己亲手做一遍？
-转场：最后进入 Q&amp;A。</a:t>
-            </a:r>
-            <a:endParaRPr lang="en-US" dirty="0"/>
-          </a:p>
-        </p:txBody>
-      </p:sp>
-      <p:sp>
-        <p:nvSpPr>
-          <p:cNvPr id="4" name="Slide Number Placeholder 3"/>
-          <p:cNvSpPr>
-            <a:spLocks noGrp="1"/>
-          </p:cNvSpPr>
-          <p:nvPr>
-            <p:ph type="sldNum" sz="quarter" idx="10"/>
-          </p:nvPr>
-        </p:nvSpPr>
-        <p:spPr/>
-        <p:txBody>
-          <a:bodyPr/>
-          <a:lstStyle/>
-          <a:p>
-            <a:fld id="{F7021451-1387-4CA6-816F-3879F97B5CBC}" type="slidenum">
-              <a:rPr lang="en-US"/>
-              <a:t>13</a:t>
-            </a:fld>
-            <a:endParaRPr lang="en-US"/>
-          </a:p>
-        </p:txBody>
-      </p:sp>
-    </p:spTree>
-    <p:extLst>
-      <p:ext uri="{BB962C8B-B14F-4D97-AF65-F5344CB8AC3E}">
-        <p14:creationId xmlns:p14="http://schemas.microsoft.com/office/powerpoint/2010/main" val="1024086991"/>
-      </p:ext>
-    </p:extLst>
-  </p:cSld>
-  <p:clrMapOvr>
-    <a:masterClrMapping/>
-  </p:clrMapOvr>
-</p:notes>
-</file>
-
-<file path=ppt/notesSlides/notesSlide14.xml><?xml version="1.0" encoding="utf-8"?>
-<p:notes xmlns:a="http://schemas.openxmlformats.org/drawingml/2006/main" xmlns:r="http://schemas.openxmlformats.org/officeDocument/2006/relationships" xmlns:p="http://schemas.openxmlformats.org/presentationml/2006/main">
-  <p:cSld>
-    <p:spTree>
-      <p:nvGrpSpPr>
-        <p:cNvPr id="1" name=""/>
-        <p:cNvGrpSpPr/>
-        <p:nvPr/>
-      </p:nvGrpSpPr>
-      <p:grpSpPr>
-        <a:xfrm>
-          <a:off x="0" y="0"/>
-          <a:ext cx="0" cy="0"/>
-          <a:chOff x="0" y="0"/>
-          <a:chExt cx="0" cy="0"/>
-        </a:xfrm>
-      </p:grpSpPr>
-      <p:sp>
-        <p:nvSpPr>
-          <p:cNvPr id="2" name="Slide Image Placeholder 1"/>
-          <p:cNvSpPr>
-            <a:spLocks noGrp="1" noRot="1" noChangeAspect="1"/>
-          </p:cNvSpPr>
-          <p:nvPr>
-            <p:ph type="sldImg"/>
-          </p:nvPr>
-        </p:nvSpPr>
-        <p:spPr/>
-      </p:sp>
-      <p:sp>
-        <p:nvSpPr>
-          <p:cNvPr id="3" name="Notes Placeholder 2"/>
-          <p:cNvSpPr>
-            <a:spLocks noGrp="1"/>
-          </p:cNvSpPr>
-          <p:nvPr>
-            <p:ph type="body" idx="1"/>
-          </p:nvPr>
-        </p:nvSpPr>
-        <p:spPr/>
-        <p:txBody>
-          <a:bodyPr/>
-          <a:lstStyle/>
-          <a:p>
-            <a:r>
-              <a:rPr lang="en-US" dirty="0"/>
-              <a:t>第 14 页：谢谢
+              <a:t>第 13 页：谢谢
 建议时长：Q&amp;A
 页内重点：致谢页：去掉上方答疑互动说明，只保留主题和互动问题。
 互动提问：围绕 AI 编程、工程治理和开发者角色继续讨论。
@@ -1008,7 +914,7 @@
           <a:p>
             <a:fld id="{F7021451-1387-4CA6-816F-3879F97B5CBC}" type="slidenum">
               <a:rPr lang="en-US"/>
-              <a:t>14</a:t>
+              <a:t>13</a:t>
             </a:fld>
             <a:endParaRPr lang="en-US"/>
           </a:p>
@@ -1077,7 +983,7 @@
 建议时长：约 0.5 分钟
 页内重点：目录页：四个大模块不超过四个，标题按用户建议调整。
 互动提问：这 15 分钟，哪些问题最值得带走？
-讲稿：这场报告分四个模块。第一是软件工程变革，先从 BitFun 的高速 AI 开发经验出发，补一页传统软件工程到人加 Agent 协作的模式变化，再推导到智能协作系统。第二是速度的背后，讨论为什么产出变快并不等于交付线性变快，以及概率性过程如何通过确定性证据获得高置信度。第三是工程质量与治理，结合外部报告和 BitFun 方法论，看质量门禁、DFX、TDD、Artifact 治理会怎样演进。第四是开发者角色，讨论人在这个系统里如何找到关键位置，而不是只停留在“会不会被替代”的问题上。
+讲稿：这场报告分四个模块。第一是软件工程变革，先从 BitFun 的高速 AI 开发经验出发，再补一页传统软件工程到人加 Agent 协作的模式变化。第二是速度的背后，讨论为什么产出变快并不等于交付线性变快，以及概率性过程如何通过确定性证据获得高置信度。第三是工程质量与治理，把质量、DFX、TDD、Artifact 与团队工作流收敛成两页方法。第四是开发者角色，讨论人在这个系统里如何找到关键位置，并给刚入职场的同学一些更可执行的能力方向。
 转场：先从一个最直观的案例入口开始：代码量变大之后，问题到底有没有变少。</a:t>
             </a:r>
             <a:endParaRPr lang="en-US" dirty="0"/>
@@ -1724,12 +1630,12 @@
           <a:p>
             <a:r>
               <a:rPr lang="en-US" dirty="0"/>
-              <a:t>第 9 页：工程质量：从门禁到智能护栏
-建议时长：约 1.4 分钟
-页内重点：突出开源与大厂场景中的责任链、证据链与小批量反制不稳定。
+              <a:t>第 9 页：工程质量：责任、证据与工程协议
+建议时长：约 1.5 分钟
+页内重点：合并质量治理与 DFX/TDD 方法演进，突出责任链、证据链、Artifact 链和工程协议。
 互动提问：AI 让提交变多以后，维护者和大厂平台到底该看什么？
-讲稿：原先第七页和第八页容易讲成重复的质量术语，这里把它收敛为一个治理问题：开源高质量协作强调公共责任，维护者要提升对陌生贡献或 AI-assisted 变更质量的信任度；大厂复杂交付强调系统连续性，组织要处理 owner、依赖链、合规、发布窗口、线上事故成本，以及贯穿整个系统的确定性工件。两者都不能只靠“多跑测试”。更有效的做法是把变化拆小，把责任、证据和 Artifact 绑定到每个小批次：谁拥有模块，谁确认设计边界，哪些测试和运行指标证明可以前进，失败时如何回滚。
-转场：再往前看，DFX、TDD、架构守护都会出现 AI 时代的新形态。</a:t>
+讲稿：这部分把原来三页收敛成两页，避免变成重复的质量术语。开源高质量协作强调公共责任：贡献者要对自己的提交负责，维护者要提升对陌生贡献或 AI-assisted 变更质量的信任度。大厂复杂交付强调系统连续性：组织要处理 owner、依赖链、合规、发布窗口、线上事故成本，以及贯穿整个系统的确定性工件。两者共同的方向，是把质量要求变成可执行证据。DFX、TDD、Code Review 不应该只停留在文档和习惯里，而要进入 Agent 能读取、工具能检查、人能复核的工程协议：性能、安全、可观测、可维护都要能落到检查项、基准、trace、回归用例和发布预算上。
+转场：这些协议真正落地时，会表现为一个可治理的团队工作流。</a:t>
             </a:r>
             <a:endParaRPr lang="en-US" dirty="0"/>
           </a:p>
@@ -2358,62 +2264,6 @@
 </p:sld>
 </file>
 
-<file path=ppt/slides/slide14.xml><?xml version="1.0" encoding="utf-8"?>
-<p:sld xmlns:a="http://schemas.openxmlformats.org/drawingml/2006/main" xmlns:r="http://schemas.openxmlformats.org/officeDocument/2006/relationships" xmlns:p="http://schemas.openxmlformats.org/presentationml/2006/main">
-  <p:cSld name="Slide 14">
-    <p:bg>
-      <p:bgPr>
-        <a:solidFill>
-          <a:srgbClr val="F6F8FB"/>
-        </a:solidFill>
-      </p:bgPr>
-    </p:bg>
-    <p:spTree>
-      <p:nvGrpSpPr>
-        <p:cNvPr id="1" name=""/>
-        <p:cNvGrpSpPr/>
-        <p:nvPr/>
-      </p:nvGrpSpPr>
-      <p:grpSpPr>
-        <a:xfrm>
-          <a:off x="0" y="0"/>
-          <a:ext cx="0" cy="0"/>
-          <a:chOff x="0" y="0"/>
-          <a:chExt cx="0" cy="0"/>
-        </a:xfrm>
-      </p:grpSpPr>
-      <p:pic>
-        <p:nvPicPr>
-          <p:cNvPr id="2" name="Image 0" descr="D:\workspace\worktree_for_vcoder\BitFun\docs\report\ai-redefines-software-development-presentation\slides-png-v0.5\slide-14.png">    </p:cNvPr>
-          <p:cNvPicPr>
-            <a:picLocks noChangeAspect="1"/>
-          </p:cNvPicPr>
-          <p:nvPr/>
-        </p:nvPicPr>
-        <p:blipFill>
-          <a:blip r:embed="rId1"/>
-          <a:stretch>
-            <a:fillRect/>
-          </a:stretch>
-        </p:blipFill>
-        <p:spPr>
-          <a:xfrm>
-            <a:off x="0" y="0"/>
-            <a:ext cx="12191695" cy="6858000"/>
-          </a:xfrm>
-          <a:prstGeom prst="rect">
-            <a:avLst/>
-          </a:prstGeom>
-        </p:spPr>
-      </p:pic>
-    </p:spTree>
-  </p:cSld>
-  <p:clrMapOvr>
-    <a:masterClrMapping/>
-  </p:clrMapOvr>
-</p:sld>
-</file>
-
 <file path=ppt/slides/slide2.xml><?xml version="1.0" encoding="utf-8"?>
 <p:sld xmlns:a="http://schemas.openxmlformats.org/drawingml/2006/main" xmlns:r="http://schemas.openxmlformats.org/officeDocument/2006/relationships" xmlns:p="http://schemas.openxmlformats.org/presentationml/2006/main">
   <p:cSld name="Slide 2">

</xml_diff>

<commit_message>
docs: update AI software development presentation
</commit_message>
<xml_diff>
--- a/docs/report/ai-redefines-software-development-presentation/ai-redefines-software-development-v0.5.pptx
+++ b/docs/report/ai-redefines-software-development-presentation/ai-redefines-software-development-v0.5.pptx
@@ -516,10 +516,10 @@
               <a:rPr lang="en-US" dirty="0"/>
               <a:t>第 1 页：AI 如何重新定义软件开发
 建议时长：约 0.5 分钟
-页内重点：首页：保留主题，强调 AI 带来的工程范式变化。
-互动提问：如果 AI 已经能写很多代码，软件工程真正该升级什么？
-讲稿：各位好，今天分享的主题还是《AI 如何重新定义软件开发》。这一版会更聚焦一个问题：AI 带来的变化不只是代码生成变快，而是软件工程开始从“管理人写代码”转向“管理人、AI、工具和证据共同协作”。BitFun 只是引子，我们不会展开项目细节，而是借它讨论未来工程系统如何吸收概率性产出、如何重新定义质量责任，以及开发者在新系统里应该站在哪里。
-转场：先看目录，四个主题从案例、速度、治理一路落到开发者角色。</a:t>
+讲述目标：建立演讲边界：讨论对象不是某个工具，而是 AI 进入研发流程后，工程协作、验证和责任如何变化。
+可选提问：如果 AI 已经能写很多代码，软件工程真正该升级什么？
+讲稿：各位好，今天分享的主题是《AI 如何重新定义软件开发》。我想先把范围说清楚：今天不做工具演示，也不做某个项目的复盘，而是借 BitFun 这个具体入口，讨论一个更大的变化。当 AI 从补全一行代码，走向能开任务、改代码、跑测试、提交 PR 时，软件开发被改变的就不只是写代码的速度。真正被改写的是工程系统本身：任务如何被委派，证据如何被沉淀，风险如何被放行，最后责任如何落到人和组织上。
+转场：先用目录把 15 分钟的路径铺开：从案例入口，到速度背后的代价，再到质量治理和开发者角色。</a:t>
             </a:r>
             <a:endParaRPr lang="en-US" dirty="0"/>
           </a:p>
@@ -608,11 +608,11 @@
             <a:r>
               <a:rPr lang="en-US" dirty="0"/>
               <a:t>第 10 页：把 AI 开发组织成可治理工作流
-建议时长：约 1.5 分钟
-页内重点：把质量治理落到可执行方法：Spec/Issue -&gt; Agent Worktree -&gt; Evidence Packet -&gt; Independent Review -&gt; Gate/Merge。
-互动提问：如果多个 Agent 同时参与，团队靠什么判断一个变更可以继续前进？
-讲稿：回到 BitFun，它不是要证明某个模型更强，而是展示一个团队工作流的雏形。更可落地的做法是把一次 AI 开发压成五个稳定环节：第一，任务从 Issue 或 Spec 进入，明确目标、非目标和风险边界；第二，Agent 在隔离工作区执行，避免把探索过程直接污染主分支；第三，执行结束必须生成证据包，包括 diff 摘要、测试结果、日志、trace、未决风险和回滚路径；第四，评审要角色分离，发现问题、仲裁问题、修复问题、验证修复尽量不要由同一个角色闭环；第五，阶段门禁决定能否进入 PR、合并或发布。这里的关键不是记录每一步操作，而是把复杂过程压缩成团队能读、能审、能追责的交付对象和证据。
-转场：最后，我们把视角切回开发者：人在这样的系统里到底做什么。</a:t>
+建议时长：约 1.3 分钟
+讲述目标：把 AI 开发压成五个稳定环节：任务入口、隔离执行、证据包、独立评审、阶段放行。
+可选提问：如果多个 Agent 同时参与，团队靠什么判断一个变更可以继续前进？
+讲稿：把前面的原则落到团队工作流，可以拆成五个稳定环节。第一，任务从 Issue 或 Spec 进入，先明确目标、非目标、验收标准和风险边界。第二，Agent 在隔离工作区执行，探索过程可以充分展开，但不能直接污染主分支。第三，执行结束必须生成证据包，包括 diff 摘要、测试结果、日志、trace、未决风险和回滚路径。第四，评审要尽量角色分离，发现问题、仲裁问题、修复问题和验证修复，不要全部压在同一个角色身上。第五，阶段门禁决定能否进入 PR、合并或发布。这个顺序很重要：没有清晰任务，后面的证据会失焦；没有隔离执行，探索会污染主线；没有证据包，评审只能靠印象；没有独立评审，修复和验证容易混在一起。每一关都应该有明确输入和输出，缺少证据就停在当前阶段，而不是靠负责人记忆补齐。这里的关键不是把所有操作都录下来，而是把复杂过程压缩成团队能读、能审、能追责的交付对象和证据。
+转场：有了这样的工作流，再看开发者角色，就不会落到人和 AI 谁替代谁的简单问题上。</a:t>
             </a:r>
             <a:endParaRPr lang="en-US" dirty="0"/>
           </a:p>
@@ -702,10 +702,10 @@
               <a:rPr lang="en-US" dirty="0"/>
               <a:t>第 11 页：开发者角色：在新工程系统中找准位置
 建议时长：约 1.5 分钟
-页内重点：收敛为四步，明确人在各阶段和 AI 在各阶段的角色。
-互动提问：AI 参与每个阶段后，人类开发者最不可替代的技能是什么？
-讲稿：对学生来说，这页很关键：未来不是“人写代码，AI 帮忙补全”，而是人在不同阶段承担不同关键角色。第一步是定义问题，人负责价值判断、非目标和风险边界，AI 可以帮助整理信息和生成备选方案。第二步是组织上下文，人负责架构取舍和事实源选择，AI 负责检索、摘要和草拟计划。第三步是编排执行，人负责设置权限、节奏、验证矩阵和停止条件，AI 负责生成、修改、运行和反馈。第四步是证据放行，人负责最终责任、质量解释和复盘沉淀，AI 提供 trace、diff、测试结果和改进建议。所以编程基础仍重要，但能力结构会从语法实现，升级到问题定义、系统判断、证据审查和协作治理。
-转场：最后把视角落到刚入职场的同学：AI 时代哪些能力更值得优先练。</a:t>
+讲述目标：明确人和 AI 在四个阶段的分工：定义问题、组织上下文、编排执行、证据放行。
+可选提问：AI 参与每个阶段后，人类开发者最不可替代的技能是什么？
+讲稿：从开发者个人角度看，未来不是人写代码、AI 做补全这么简单，而是人在不同阶段承担不同责任。第一阶段是定义问题，人负责价值判断、非目标和风险边界，AI 可以帮助整理信息和生成备选方案。第二阶段是组织上下文，人负责架构取舍、事实源选择和约束解释，AI 负责检索、摘要和草拟计划。第三阶段是编排执行，人负责设置权限、节奏、验证矩阵和停止条件，AI 负责生成、修改、运行和反馈。第四阶段是证据放行，人负责最终责任、质量解释和复盘沉淀，AI 提供 trace、diff、测试结果和改进建议。这里不是说开发者离代码越来越远，相反，只有理解代码、架构和运行约束，才知道该给 AI 什么上下文、该相信哪些证据、该在什么地方停下来。越是 AI 能快速完成表层实现，越要把人的时间放在问题选择、事实核验和风险解释上。编程基础仍然重要，但能力结构会从语法实现，升级到问题定义、系统判断、证据审查和协作治理。人的价值不是站在 AI 旁边看它写代码，而是在目标、边界、证据和责任上站稳，并把机器产出转化成团队可以放心承接的工程结果。
+转场：最后把这个判断落到新人工程师身上：第一年最应该训练哪些能力。</a:t>
             </a:r>
             <a:endParaRPr lang="en-US" dirty="0"/>
           </a:p>
@@ -795,10 +795,10 @@
               <a:rPr lang="en-US" dirty="0"/>
               <a:t>第 12 页：刚入职场：四个能力方向
 建议时长：约 1.1 分钟
-页内重点：结合最新调研与论文，把开发者角色变化落到新人工程师可执行的能力方向。
-互动提问：当 AI 可以帮你更快完成任务，第一年最应该刻意训练什么？
-讲稿：最后把问题落到刚入职场的同学。外部信号其实很一致：Stack Overflow 2025 里 84% 开发者使用或计划使用 AI，但 46% 不信任 AI 输出准确性；Anthropic 2026 的受控实验显示，使用 AI 的参与者在刚学新库后的概念测验中低 17%，尤其是调试和理解能力受影响；Sonar 2026 则显示 AI 已经占到相当比例的提交代码，但只有不到一半开发者总是提交前验证。也就是说，新人的问题不是要不要用 AI，而是如何不把成长路径外包给 AI。这里给四个更可执行的方向。第一，保留代码读写与调试基本功：至少能解释核心实现、能复现错误、能定位边界条件。第二，训练证据驱动交付：把测试、CI、日志、trace、review 作为交付的一部分，而不是写完代码后的附属品。第三，理解需求与用户场景：软件工程师不会只承担单纯开发角色，要逐步理解用户路径、产品定位、体验约束和验收标准，才能把 AI 生成结果放进正确问题里。第四，承担责任边界：AI 可以生成和修复，人仍然要判断该不该做、能不能合、出了问题如何解释。对新人来说，更实际的升级路径是把“能写代码”升级为“能理解问题并可靠交付”，在需求理解、证据交付和责任判断上建立自己的专业位置。
-转场：最后进入 Q&amp;A。</a:t>
+讲述目标：给新人明确训练方向：读懂代码、证据交付、理解场景、承担责任边界。
+可选提问：当 AI 可以帮你更快完成任务，第一年最应该刻意训练什么？
+讲稿：对刚入职场的人来说，关键不是要不要用 AI，而是不要把成长路径外包给 AI。外部调研已经很清楚：大量开发者在使用或准备使用 AI，但对输出准确性的信任并不高；一些受控实验也提示，过度依赖 AI 可能影响调试和理解能力。更稳妥的训练方向有四个。第一，读懂与解释代码，至少能复现错误、读懂 diff、解释关键实现和边界条件。第二，证据驱动交付，把测试、CI、日志、trace 和 review 当成交付的一部分，而不是写完代码后的附属品。第三，理解需求与场景，知道用户路径、产品定位、体验约束和验收标准。第四，承担责任边界，能判断该不该做、能不能合、出了问题如何解释。使用 AI 时，可以让它帮你生成方案，但要逼自己说清为什么这样做、怎么验证、失败了怎么回滚。把能写代码升级为能理解问题并可靠交付，这会是新人最重要的专业位置。
+转场：最后用两个问题收束，进入交流。</a:t>
             </a:r>
             <a:endParaRPr lang="en-US" dirty="0"/>
           </a:p>
@@ -887,11 +887,11 @@
             <a:r>
               <a:rPr lang="en-US" dirty="0"/>
               <a:t>第 13 页：谢谢
-建议时长：Q&amp;A
-页内重点：致谢页：去掉上方答疑互动说明，只保留主题和互动问题。
-互动提问：围绕 AI 编程、工程治理和开发者角色继续讨论。
-讲稿：以上就是主要内容。最后留两个问题和一个方向给大家：如果 AI 能显著扩大个人产出，团队还应该用什么指标判断真实收益？如果执行过程允许概率性，哪些证据必须保持确定性？以及开发者的技术成长会向哪些方向延伸，比如架构判断、上下文组织、证据设计和工程治理。接下来进入答疑互动。
-转场：答疑互动。</a:t>
+建议时长：约 0.8 分钟（收束 + Q&amp;A 入口）
+讲述目标：收束主旨并把讨论引向收益指标、确定性证据和开发者成长。
+可选提问：AI 编程真正值得追踪的收益指标、证据指标和成长指标分别是什么？
+讲稿：最后把今天的内容收束成三句话。第一，AI 扩大了个人产出，但团队不能只看代码量，而要看净交付时间、返工率、评审压力和线上风险。第二，AI 的执行过程可以概率化，但放行必须依赖确定性证据，包括测试、trace、风险说明、owner 和回滚路径。第三，开发者的成长不会停留在会不会写代码，而会更多转向架构判断、上下文组织、证据设计和工程治理。如果只把 AI 当成写代码工具，会低估它对流程的影响；如果只把 AI 当成替代人，也会低估人在目标、边界和责任上的价值。接下来可以围绕 AI 编程、工程治理和开发者角色继续交流。
+转场：进入 Q&amp;A。</a:t>
             </a:r>
             <a:endParaRPr lang="en-US" dirty="0"/>
           </a:p>
@@ -980,11 +980,11 @@
             <a:r>
               <a:rPr lang="en-US" dirty="0"/>
               <a:t>第 2 页：报告目录
-建议时长：约 0.5 分钟
-页内重点：目录页：四个大模块不超过四个，标题按用户建议调整。
-互动提问：这 15 分钟，哪些问题最值得带走？
-讲稿：这场报告分四个模块。第一是软件工程变革，先从 BitFun 的高速 AI 开发经验出发，再补一页传统软件工程到人加 Agent 协作的模式变化。第二是速度的背后，讨论为什么产出变快并不等于交付线性变快，以及概率性过程如何通过确定性证据获得高置信度。第三是工程质量与治理，把质量、DFX、TDD、Artifact 与团队工作流收敛成两页方法。第四是开发者角色，讨论人在这个系统里如何找到关键位置，并给刚入职场的同学一些更可执行的能力方向。
-转场：先从一个最直观的案例入口开始：代码量变大之后，问题到底有没有变少。</a:t>
+建议时长：约 0.6 分钟
+讲述目标：说明四段主线：产出放大、速度代价、质量治理、开发者角色。
+可选提问：这 15 分钟里，大家最想带走的是工具判断、工程方法，还是个人成长路径？
+讲稿：今天会沿着四段往下讲。第一段从一个很具体的现象开始：当 AI 让一个项目在短时间内产生大量代码，问题是不是就少了，还是被转移到了验证和维护上。第二段看速度背后，为什么局部开发变快，不等于团队交付天然变快。第三段讨论质量治理，重点不是再加一层审批，而是让责任、证据和工程协议变得可执行。第四段回到开发者本人，尤其是刚进入职场的人，应该把能力训练放在哪里。听完之后，希望大家带走的不是某个工具结论，而是一套判断 AI 研发收益和风险的工程视角。
+转场：先看第一个现象：代码量突然放大之后，团队真正面对的压力是什么。</a:t>
             </a:r>
             <a:endParaRPr lang="en-US" dirty="0"/>
           </a:p>
@@ -1074,10 +1074,10 @@
               <a:rPr lang="en-US" dirty="0"/>
               <a:t>第 3 页：单月 10W+ 行代码之后，问题真的变少了吗？
 建议时长：约 1.4 分钟
-页内重点：先案例后抽象：把 BitFun 作为实际入口，而不是先讲概念。
-互动提问：如果一个项目单月写出 10W+ 行代码，第一反应该是兴奋还是审计？
-讲稿：先从一个具体入口看：在 GCWing/BitFun 仓库里，以 2026 年 4 月 22 日到 5 月 22 日的一个月窗口统计，作者 limityan 在 main 分支上有 241 个提交，新增 185,533 行、删除 46,479 行。这个统计口径不用于证明代码越多越好，而是作为一个压力测试入口：当代码生产速度被 AI 放大以后，需求变化会更频繁，原型可以更快从想法变成可运行样例，个人也可以先完成过去需要小团队配合的探索工作；与此同时，测试、review、架构理解、运行验证、知识沉淀不一定同步扩张。也就是说，代码量的膨胀不一定带来交付节奏等比例膨胀，它更像是把系统瓶颈从“写不出来”推向“能否验证、能否维护、能否协作、能否上线”。
-转场：由这个案例往上推，就能看到 AI 时代软件工程对象正在发生扩张。</a:t>
+讲述目标：用 BitFun 统计做压力测试：代码产出扩大后，瓶颈转向验证、维护、协作和上线。
+可选提问：如果一个项目单月写出 10W+ 行代码，第一反应该是兴奋，还是先问怎么验证？
+讲稿：先看一个具体数字。在 GCWing/BitFun 仓库里，以 2026 年 4 月 22 日到 5 月 22 日为窗口，作者 limityan 在 main 分支上有 241 个提交，新增 185,533 行，删除 46,479 行。这个数字不是为了说明代码越多越好，而是一个很好的压力测试：当 AI 把代码生产速度放大之后，原型可以更快落地，想法可以更快变成 PR，个人也能承担过去需要多人协同的探索工作。但同一时间，测试、review、架构理解、运行验证和知识沉淀不会自动同速扩张。可以把注意力放在右侧的 Git 快照和下方的快速路径上：代码进入仓库变快了，反馈路径也要跟上，否则快只是把问题更早推到 reviewer、CI 和线上环境里。所以真正的问题从“能不能写出来”转向“凭什么能合并、凭什么能发布、出了问题谁解释、长期谁维护”。速度带来的不是单纯收益，而是把系统瓶颈暴露得更快，也要求团队用新的方式组织验证和协作。它更像放大镜，暴露了原来就存在但不够显性的工程压力。
+转场：如果顺着这个现象往上看，软件工程要管理的对象就不再只是代码本身。</a:t>
             </a:r>
             <a:endParaRPr lang="en-US" dirty="0"/>
           </a:p>
@@ -1166,11 +1166,11 @@
             <a:r>
               <a:rPr lang="en-US" dirty="0"/>
               <a:t>第 4 页：主线：产出放大后，协作对象变了
-建议时长：约 1.2 分钟
-页内重点：承接 BitFun 案例，说明代码产出放大后，协作对象从代码扩展到任务委派、角色分工、证据放行，并用实际文档/验证片段展示证据形态。
-互动提问：当 Agent 也能开分支、跑测试、提交 PR 时，团队到底要管理什么？
-讲稿：由 BitFun 的高速开发经验往上推，主线不是“AI 多写了代码”，而是协作对象变了。过去我们主要管理人和人之间的协作，以及代码进入仓库的流程；现在多了异步 Agent、角色化 Agent、工具执行、测试结果、trace、风险说明和回滚路径。这页只讲三个变化。第一，任务委派：你不只是让 AI 写一段代码，而是把目标、非目标、影响范围和验收标准交给 Agent，让它在独立工作区探索。第二，角色分工：实现、测试、评审、安全、文档不一定由同一个 Agent 或同一个流程完成，团队要管理权限、上下文和生命周期。第三，证据放行：人看的重点不是每一步 prompt，而是目标是否明确、证据是否足够、风险是否可接受、责任是否能落地。所以 AI 时代的软件工程，不是多一个助手，而是把任务、证据和责任一起纳入协作系统。
-转场：协作对象变多以后，真正的治理问题就出现了：AI 可以概率性探索，但系统必须确定性放行。</a:t>
+建议时长：约 1.3 分钟
+讲述目标：把协作对象从代码扩展到任务、Agent、工具执行、证据包和责任链。
+可选提问：当 Agent 也能开分支、跑测试、提交 PR 时，团队到底应该管理什么？
+讲稿：过去谈协作，很多时候是在谈人和人怎么分工，代码怎么进入仓库，PR 怎么被 review。AI Agent 进入之后，协作对象变多了：有异步执行的 Agent，有专门负责实现、测试、评审或文档的角色，有工具调用结果，有 trace，有风险说明，也有回滚路径。左边三个动作可以概括这种变化。第一是任务委派，目标、非目标、影响范围和验收标准要先清楚，否则 Agent 只是在放大模糊需求。第二是角色分工，不同 Agent 可以做不同事，但权限、上下文和生命周期必须受控，不能让所有能力混在一个无限权限的聊天窗口里。第三是证据放行，人不需要盯住每一步操作，但必须能看懂差异、测试、风险和责任。比如一个 issue 不只是需求描述，还应该带上验收标准；一个 PR 不只是 diff，还应该带上测试、trace 和回滚说明。也就是说，AI 时代的软件工程是在管理一个协作系统，而不是只管理代码提交。
+转场：协作对象变多以后，下一个关键问题就是：过程可以探索，但结果怎样才能被放行。</a:t>
             </a:r>
             <a:endParaRPr lang="en-US" dirty="0"/>
           </a:p>
@@ -1259,11 +1259,11 @@
             <a:r>
               <a:rPr lang="en-US" dirty="0"/>
               <a:t>第 5 页：从传统 SDLC 到人 + Agent SDLC
-建议时长：约 1.0 分钟
-页内重点：为高校听众补齐复杂项目中的角色、流程和交付件，再说明 AI 进入后变化在哪里。
-互动提问：如果没有做过完整复杂项目，怎么理解软件工程不是“写代码”这一件事？
-讲稿：为了避免把软件工程讲成抽象概念，这里补一页传统模式。过去一个完整项目通常不是一个人从头写到尾，而是产品定义需求和验收，设计给出交互和视觉，开发拆分模块和接口，测试建立用例和回归，运维关注发布、监控和故障恢复。每个角色都有交付件：PRD、设计稿、接口文档、代码和 PR、测试报告、发布记录、监控告警。AI 进入以后，角色不会简单消失，但交付件会变化。产品和开发要把目标、非目标、边界和验收标准写得更清楚；Agent 在隔离工作区里生成计划、代码、测试和日志；平台用 CI、权限、trace 和风险规则做阶段门禁；人类负责最终取舍、责任解释和发布放行。这个变化的核心是：软件工程从人和人之间交接文档，变成 人、人、Agent、Agent 与平台共同维护可验证证据。
-转场：有了这个完整流程视角，再讨论概率过程和证据放行就更具体。</a:t>
+建议时长：约 1.2 分钟
+讲述目标：解释 SDLC 中每个角色的交付件如何从文档交接转向可验证证据。
+可选提问：如果没有做过完整复杂项目，怎么理解软件工程不只是写代码？
+讲稿：软件开发本来就不是一个人从头写到尾。产品负责需求和验收，设计负责交互和接口约束，开发负责模块、代码和 PR，测试负责用例、报告和回归，运维负责发布、监控和恢复。AI 进入之后，这些角色不会消失，但交付件的形态会变化。产品和开发要把目标、边界、场景和验收标准写得更结构化；设计约束、ADR 和例外情况要更显性；开发不只是交出代码，还要交出计划、diff 和 trace；测试不只是跑用例，还要形成连续证据；运维的回滚、复盘和学习也会回到系统里。换句话说，每个角色都需要把过去靠经验口头传递的内容，转成 Agent 能执行、工具能检查、人能判断的对象。核心变化是从“人交接文档”转向“Agent 可执行、人可判断、平台可验证的证据”。这也是为什么 AI 不是替代 SDLC，而是在重新定义 SDLC 里的交付物。
+转场：有了这个流程视角，再看概率过程和证据放行，会更容易理解为什么需要新的工程机制。</a:t>
             </a:r>
             <a:endParaRPr lang="en-US" dirty="0"/>
           </a:p>
@@ -1352,11 +1352,11 @@
             <a:r>
               <a:rPr lang="en-US" dirty="0"/>
               <a:t>第 6 页：关键机制：概率过程，证据放行
-建议时长：约 1.6 分钟
-页内重点：说明如何用 Harness 保护、证据包、阶段门禁和人工判断收敛概率性过程。
-互动提问：如果每一步都有 99% 正确率，十步之后系统还可信吗？
-讲稿：这页是前面协作变化之后的关键机制：我们不要求 AI 的每一步都确定正确，而是允许过程概率性探索，同时把结果放行建立在确定性证据上。AI 的不确定性不只来自某一次回答，团队里不同人可能使用不同模型，同一模型不同版本能力也会波动；如果一个 Agent Team 中每一步都把前一步结论当事实输入，错误会像串联系统一样累乘，0.99 的十次方大约只有 0.90。解决办法不是让人类盯住每一步 prompt，而是建立阶段门禁和证据包。左边是概率探索层，Harness 要提供沙箱、权限、危险操作拦截、失败回注和 trace；中间是证据包，把 diff、测试、日志、风险、回滚路径压缩成人能判断的交付对象；右边是阶段门禁，在计划到实现、实现到评审、评审到合并这些阶段转换处检查完整性、契约、测试、owner 和风险。人类参与的重点也从过程监督变成判断辅助：看摘要、差异、来源、不一致提示和风险解释。也就是说，用可控系统解决不可控过程，核心不是记录更多细节，而是把复杂过程收敛为可审查、可复现、可回滚的证据。
-转场：有了这层纠偏系统，再看外部数据，会更容易理解为什么速度收益不是天然指数级增长。</a:t>
+建议时长：约 1.4 分钟
+讲述目标：解释可控系统如何收敛不可控过程：沙箱、权限、证据包和阶段门禁各承担什么责任。
+可选提问：如果每一步都有 99% 正确率，十步之后系统还可信吗？
+讲稿：AI 参与软件工程后，一个重要观念是：过程可以是概率性的，但放行不能只靠概率。比如每一步看起来都有 99% 的正确率，十步串起来大约只剩 0.90，这还没有考虑模型版本变化、上下文缺失、工具返回异常和角色之间相互放大错误。解决方法不是让人盯住每一步 prompt，而是把过程放进可控系统。左侧是概率探索层，沙箱执行、权限控制、失败回注和 trace 回放，让过程可观察、可停下、可追责。中间是证据包，把 diff、测试、风险和回滚路径压缩成可判断对象。右侧是阶段门禁，只在计划到实现、实现到评审、评审到合并、发布到复盘这些转换点做放行判断。这里的关键是把不确定性限制在探索空间里，把确定性建立在证据和门禁上。人的重点不是监督每个动作，而是判断证据是否足够、风险是否可接受、责任是否清楚。这样既保留 Agent 多路径探索的效率，也避免把概率性输出直接推到生产链路里。模型给可能性，工程系统要给可复现性和可追责性。
+转场：这套机制解释了为什么 AI 很快，但组织收益不会天然按指数增长。</a:t>
             </a:r>
             <a:endParaRPr lang="en-US" dirty="0"/>
           </a:p>
@@ -1446,10 +1446,10 @@
               <a:rPr lang="en-US" dirty="0"/>
               <a:t>第 7 页：速度收益不是指数曲线
 建议时长：约 1.2 分钟
-页内重点：补外部信息：DORA、METR、Harness 作为市场和研究佐证。
-互动提问：为什么开发者感觉更快，团队整体却未必同等加速？
-讲稿：外部研究给了我们一个更冷静的视角。DORA 2025 把 AI 描述为组织系统的放大器：高质量组织会被放大，原本碎片化的流程也会被放大；同时它也提醒，采用 AI 不等于自动获得收益，组织需要同步演进文化、流程和系统。METR 在 2025 对成熟开源项目做随机对照实验，发现经验开发者使用当时的 AI 工具反而慢 19%；2026 年 METR 又提醒，AI 工具正在进化，任务选择和多 Agent 使用让测量本身也变难。Harness 2026 则把问题落到工程管理上：很多团队的生产力指标变好，但 code review、修 bug、工具切换等隐形工作也在上升。结论不是 AI 没用，而是不要只用代码量衡量收益。
-转场：所以第一个真正被重新定义的东西，是质量责任。</a:t>
+讲述目标：用 DORA、METR、Harness 三类外部信号说明：局部加速会把隐藏工作推到评审、修复和集成环节。
+可选提问：为什么开发者感觉更快，团队整体却未必同等加速？
+讲稿：外部研究也在提醒同一件事：AI 带来的速度收益不是一条简单的指数曲线。DORA 2025 把 AI 看成组织系统的放大器，高质量组织会被放大，碎片化流程也会被放大；工具采用本身并不自动等于收益。METR 在成熟开源项目上做过随机对照实验，发现经验开发者使用当时的 AI 工具反而慢 19%，这说明熟悉代码库、理解上下文、处理边界条件仍然很重。Harness 2026 把问题放到工程管理上：很多团队的局部生产力指标变好，但 code review、修 bug、工具切换和验证工作也在增加。三个信号要合在一起看：AI 可以让局部动作更快，但组织收益取决于系统是否能吸收这些变化。结论不是 AI 没用，而是速度收益必须和验证成本、返工成本、评审压力一起衡量。如果只统计写了多少代码，就会高估收益；如果能统计从需求到稳定发布的净时间，才更接近真实生产力。
+转场：所以接下来要看速度的代价：返工和风险怎样从隐形成本变成可管理队列。</a:t>
             </a:r>
             <a:endParaRPr lang="en-US" dirty="0"/>
           </a:p>
@@ -1539,10 +1539,10 @@
               <a:rPr lang="en-US" dirty="0"/>
               <a:t>第 8 页：速度的代价：把返工变成可管理队列
 建议时长：约 1.3 分钟
-页内重点：把速度提升后的隐形成本落到可执行的度量、分流和修复闭环。
-互动提问：当 AI 让代码进入仓库的速度变快，团队怎样避免 review、返工和集成变成新瓶颈？
-讲稿：前一页说速度收益不是指数曲线，这一页回答“代价该怎么处理”。AI 让写代码变快以后，新的瓶颈通常不是打字速度，而是 review 队列、返工循环、CI 不稳定、跨团队集成和线上恢复。第一步要把成本显性化：不要只看生成了多少代码，而要看从需求到可验证结果的净时间、PR 等待、返工率、失败重跑、MTTR。METR 的开源开发者实验提醒我们，熟悉项目里使用 AI 也可能变慢；Harness 的报告则说明，评审、修 bug、工具切换会成为隐形工作。第二步是入口风险分流：不是所有 AI 变更都走同一条审批线，而是按 owner、diff 大小、模块热度、SLO 影响做风险打标，低风险自动验证，高风险进入设计和人工评审。第三步是闭环修复：SWE-CI 把 Agent 评估放进连续集成循环，SWE-PRBench 提醒 AI 评审还不能当最终裁决，AgentTrace 和 AgentRx 这类工作则把失败步骤和根因变成可定位对象。这样速度提升才不会把成本甩给最后一个 reviewer，而是进入一个可度量、可分流、可修复的工程队列。
-转场：把代价管住以后，下一步才是讨论开源和大厂场景下的质量治理形态。</a:t>
+讲述目标：给出三个落地动作：量化净时间、按风险分流、让失败回到 Agent 与 CI 闭环。
+可选提问：当 AI 让代码进入仓库的速度变快，团队怎样避免 review、返工和集成变成新瓶颈？
+讲稿：当写代码变快以后，新的瓶颈往往不在键盘上，而在 review 队列、返工循环、CI 稳定性、跨团队集成和线上恢复。处理办法不是简单多加审批，而是把返工变成可管理队列。第一步是量化代价，看净时间而不是代码量：从需求到可验证结果用了多久，PR 等待多久，返工率是多少，失败重跑多少次，MTTR 有没有变差。第二步是风险分流，不是所有 AI 变更都走同一条线，而是按 owner、diff 大小、模块热度和 SLO 影响打标；低风险自动验证，高风险进入设计和人工评审。第三步是闭环修复，让 CI 失败、trace 归因、根因复盘回到 Agent 和工程系统。这样做的好处是，团队不用靠最后一个 reviewer 硬扛所有不确定性，而是把不同风险的变更排进不同队列。队列本身也要有优先级和退出标准，否则低风险和高风险混在一起，速度会被平均掉。速度提升才不会把成本甩给流程末端，而是进入可度量、可排队、可修复的流程。
+转场：速度和返工被纳入管理之后，质量治理才有可能真正落地。</a:t>
             </a:r>
             <a:endParaRPr lang="en-US" dirty="0"/>
           </a:p>
@@ -1631,11 +1631,11 @@
             <a:r>
               <a:rPr lang="en-US" dirty="0"/>
               <a:t>第 9 页：工程质量：责任、证据与工程协议
-建议时长：约 1.5 分钟
-页内重点：合并质量治理与 DFX/TDD 方法演进，突出责任链、证据链、Artifact 链和工程协议。
-互动提问：AI 让提交变多以后，维护者和大厂平台到底该看什么？
-讲稿：这部分把原来三页收敛成两页，避免变成重复的质量术语。开源高质量协作强调公共责任：贡献者要对自己的提交负责，维护者要提升对陌生贡献或 AI-assisted 变更质量的信任度。大厂复杂交付强调系统连续性：组织要处理 owner、依赖链、合规、发布窗口、线上事故成本，以及贯穿整个系统的确定性工件。两者共同的方向，是把质量要求变成可执行证据。DFX、TDD、Code Review 不应该只停留在文档和习惯里，而要进入 Agent 能读取、工具能检查、人能复核的工程协议：性能、安全、可观测、可维护都要能落到检查项、基准、trace、回归用例和发布预算上。
-转场：这些协议真正落地时，会表现为一个可治理的团队工作流。</a:t>
+建议时长：约 1.4 分钟
+讲述目标：区分开源与大厂场景，但落到同一个核心：质量要求必须变成可复核工件。
+可选提问：AI 让提交变多以后，维护者和平台团队到底该看什么？
+讲稿：质量治理在不同场景里重点不同。开源项目更强调公共责任：贡献者要对自己的提交负责，维护者要能判断陌生贡献和 AI-assisted 变更是否值得信任。大厂复杂交付更强调系统连续性：一个变更会牵涉 owner、依赖链、合规、发布窗口和线上事故成本。两边看似不同，但核心一致：质量要求不能停留在口头承诺或文档口号里，必须变成可复核工件。责任链说明谁决策、谁审核、谁承担后果；证据链说明测试、日志、trace、风险和回滚路径是否完整；Artifact 链说明代码、配置、依赖、发布物和运行数据如何互相追踪。比如一个变更影响了鉴权、计费或发布流程，不能只写“已自测”，而要能看到相关用例、风险说明、owner 确认和回滚方案。这样维护者不必猜测变更可信不可信，而是围绕证据做判断。DFX、TDD、Code Review 也应该从人的流程习惯，逐步变成 Agent 能读取、工具能检查、人能复核的工程协议。质量治理的重点不是让流程更重，而是让判断有依据。
+转场：当这些协议进入真实流程，就会形成从 Issue 到 PR 的可治理工作流。</a:t>
             </a:r>
             <a:endParaRPr lang="en-US" dirty="0"/>
           </a:p>
@@ -2010,7 +2010,7 @@
       </p:grpSpPr>
       <p:pic>
         <p:nvPicPr>
-          <p:cNvPr id="2" name="Image 0" descr="D:\workspace\worktree_for_vcoder\BitFun\docs\report\ai-redefines-software-development-presentation\slides-png-v0.5\slide-01.png">    </p:cNvPr>
+          <p:cNvPr id="2" name="Image 0" descr="D:\workspace\limityan\BitFun\docs\report\ai-redefines-software-development-presentation\slides-png-v0.5\slide-01.png">    </p:cNvPr>
           <p:cNvPicPr>
             <a:picLocks noChangeAspect="1"/>
           </p:cNvPicPr>
@@ -2066,7 +2066,7 @@
       </p:grpSpPr>
       <p:pic>
         <p:nvPicPr>
-          <p:cNvPr id="2" name="Image 0" descr="D:\workspace\worktree_for_vcoder\BitFun\docs\report\ai-redefines-software-development-presentation\slides-png-v0.5\slide-10.png">    </p:cNvPr>
+          <p:cNvPr id="2" name="Image 0" descr="D:\workspace\limityan\BitFun\docs\report\ai-redefines-software-development-presentation\slides-png-v0.5\slide-10.png">    </p:cNvPr>
           <p:cNvPicPr>
             <a:picLocks noChangeAspect="1"/>
           </p:cNvPicPr>
@@ -2122,7 +2122,7 @@
       </p:grpSpPr>
       <p:pic>
         <p:nvPicPr>
-          <p:cNvPr id="2" name="Image 0" descr="D:\workspace\worktree_for_vcoder\BitFun\docs\report\ai-redefines-software-development-presentation\slides-png-v0.5\slide-11.png">    </p:cNvPr>
+          <p:cNvPr id="2" name="Image 0" descr="D:\workspace\limityan\BitFun\docs\report\ai-redefines-software-development-presentation\slides-png-v0.5\slide-11.png">    </p:cNvPr>
           <p:cNvPicPr>
             <a:picLocks noChangeAspect="1"/>
           </p:cNvPicPr>
@@ -2178,7 +2178,7 @@
       </p:grpSpPr>
       <p:pic>
         <p:nvPicPr>
-          <p:cNvPr id="2" name="Image 0" descr="D:\workspace\worktree_for_vcoder\BitFun\docs\report\ai-redefines-software-development-presentation\slides-png-v0.5\slide-12.png">    </p:cNvPr>
+          <p:cNvPr id="2" name="Image 0" descr="D:\workspace\limityan\BitFun\docs\report\ai-redefines-software-development-presentation\slides-png-v0.5\slide-12.png">    </p:cNvPr>
           <p:cNvPicPr>
             <a:picLocks noChangeAspect="1"/>
           </p:cNvPicPr>
@@ -2234,7 +2234,7 @@
       </p:grpSpPr>
       <p:pic>
         <p:nvPicPr>
-          <p:cNvPr id="2" name="Image 0" descr="D:\workspace\worktree_for_vcoder\BitFun\docs\report\ai-redefines-software-development-presentation\slides-png-v0.5\slide-13.png">    </p:cNvPr>
+          <p:cNvPr id="2" name="Image 0" descr="D:\workspace\limityan\BitFun\docs\report\ai-redefines-software-development-presentation\slides-png-v0.5\slide-13.png">    </p:cNvPr>
           <p:cNvPicPr>
             <a:picLocks noChangeAspect="1"/>
           </p:cNvPicPr>
@@ -2290,7 +2290,7 @@
       </p:grpSpPr>
       <p:pic>
         <p:nvPicPr>
-          <p:cNvPr id="2" name="Image 0" descr="D:\workspace\worktree_for_vcoder\BitFun\docs\report\ai-redefines-software-development-presentation\slides-png-v0.5\slide-02.png">    </p:cNvPr>
+          <p:cNvPr id="2" name="Image 0" descr="D:\workspace\limityan\BitFun\docs\report\ai-redefines-software-development-presentation\slides-png-v0.5\slide-02.png">    </p:cNvPr>
           <p:cNvPicPr>
             <a:picLocks noChangeAspect="1"/>
           </p:cNvPicPr>
@@ -2346,7 +2346,7 @@
       </p:grpSpPr>
       <p:pic>
         <p:nvPicPr>
-          <p:cNvPr id="2" name="Image 0" descr="D:\workspace\worktree_for_vcoder\BitFun\docs\report\ai-redefines-software-development-presentation\slides-png-v0.5\slide-03.png">    </p:cNvPr>
+          <p:cNvPr id="2" name="Image 0" descr="D:\workspace\limityan\BitFun\docs\report\ai-redefines-software-development-presentation\slides-png-v0.5\slide-03.png">    </p:cNvPr>
           <p:cNvPicPr>
             <a:picLocks noChangeAspect="1"/>
           </p:cNvPicPr>
@@ -2402,7 +2402,7 @@
       </p:grpSpPr>
       <p:pic>
         <p:nvPicPr>
-          <p:cNvPr id="2" name="Image 0" descr="D:\workspace\worktree_for_vcoder\BitFun\docs\report\ai-redefines-software-development-presentation\slides-png-v0.5\slide-04.png">    </p:cNvPr>
+          <p:cNvPr id="2" name="Image 0" descr="D:\workspace\limityan\BitFun\docs\report\ai-redefines-software-development-presentation\slides-png-v0.5\slide-04.png">    </p:cNvPr>
           <p:cNvPicPr>
             <a:picLocks noChangeAspect="1"/>
           </p:cNvPicPr>
@@ -2458,7 +2458,7 @@
       </p:grpSpPr>
       <p:pic>
         <p:nvPicPr>
-          <p:cNvPr id="2" name="Image 0" descr="D:\workspace\worktree_for_vcoder\BitFun\docs\report\ai-redefines-software-development-presentation\slides-png-v0.5\slide-05.png">    </p:cNvPr>
+          <p:cNvPr id="2" name="Image 0" descr="D:\workspace\limityan\BitFun\docs\report\ai-redefines-software-development-presentation\slides-png-v0.5\slide-05.png">    </p:cNvPr>
           <p:cNvPicPr>
             <a:picLocks noChangeAspect="1"/>
           </p:cNvPicPr>
@@ -2514,7 +2514,7 @@
       </p:grpSpPr>
       <p:pic>
         <p:nvPicPr>
-          <p:cNvPr id="2" name="Image 0" descr="D:\workspace\worktree_for_vcoder\BitFun\docs\report\ai-redefines-software-development-presentation\slides-png-v0.5\slide-06.png">    </p:cNvPr>
+          <p:cNvPr id="2" name="Image 0" descr="D:\workspace\limityan\BitFun\docs\report\ai-redefines-software-development-presentation\slides-png-v0.5\slide-06.png">    </p:cNvPr>
           <p:cNvPicPr>
             <a:picLocks noChangeAspect="1"/>
           </p:cNvPicPr>
@@ -2570,7 +2570,7 @@
       </p:grpSpPr>
       <p:pic>
         <p:nvPicPr>
-          <p:cNvPr id="2" name="Image 0" descr="D:\workspace\worktree_for_vcoder\BitFun\docs\report\ai-redefines-software-development-presentation\slides-png-v0.5\slide-07.png">    </p:cNvPr>
+          <p:cNvPr id="2" name="Image 0" descr="D:\workspace\limityan\BitFun\docs\report\ai-redefines-software-development-presentation\slides-png-v0.5\slide-07.png">    </p:cNvPr>
           <p:cNvPicPr>
             <a:picLocks noChangeAspect="1"/>
           </p:cNvPicPr>
@@ -2626,7 +2626,7 @@
       </p:grpSpPr>
       <p:pic>
         <p:nvPicPr>
-          <p:cNvPr id="2" name="Image 0" descr="D:\workspace\worktree_for_vcoder\BitFun\docs\report\ai-redefines-software-development-presentation\slides-png-v0.5\slide-08.png">    </p:cNvPr>
+          <p:cNvPr id="2" name="Image 0" descr="D:\workspace\limityan\BitFun\docs\report\ai-redefines-software-development-presentation\slides-png-v0.5\slide-08.png">    </p:cNvPr>
           <p:cNvPicPr>
             <a:picLocks noChangeAspect="1"/>
           </p:cNvPicPr>
@@ -2682,7 +2682,7 @@
       </p:grpSpPr>
       <p:pic>
         <p:nvPicPr>
-          <p:cNvPr id="2" name="Image 0" descr="D:\workspace\worktree_for_vcoder\BitFun\docs\report\ai-redefines-software-development-presentation\slides-png-v0.5\slide-09.png">    </p:cNvPr>
+          <p:cNvPr id="2" name="Image 0" descr="D:\workspace\limityan\BitFun\docs\report\ai-redefines-software-development-presentation\slides-png-v0.5\slide-09.png">    </p:cNvPr>
           <p:cNvPicPr>
             <a:picLocks noChangeAspect="1"/>
           </p:cNvPicPr>

</xml_diff>